<commit_message>
feat(clinical-ai): integrate Monk scale, Optical IQA, friction suppression, and epistemic uncertainty
</commit_message>
<xml_diff>
--- a/submission_files/OmniCare_AI_Snapdragon_Pitch_Presentation.pptx
+++ b/submission_files/OmniCare_AI_Snapdragon_Pitch_Presentation.pptx
@@ -3112,11 +3112,11 @@
             <a:avLst/>
           </a:prstGeom>
           <a:solidFill>
-            <a:srgbClr val="070B14"/>
+            <a:srgbClr val="050811"/>
           </a:solidFill>
           <a:ln>
             <a:solidFill>
-              <a:srgbClr val="070B14"/>
+              <a:srgbClr val="050811"/>
             </a:solidFill>
           </a:ln>
         </p:spPr>
@@ -3167,12 +3167,12 @@
             <a:pPr>
               <a:defRPr sz="1200" b="1">
                 <a:solidFill>
-                  <a:srgbClr val="00D9FF"/>
-                </a:solidFill>
-              </a:defRPr>
-            </a:pPr>
-            <a:r>
-              <a:t>QUALCOMM SNAPDRAGON® AI LAB  •  HP OMNIBOOK X  •  45 TOPS HEXAGON NPU</a:t>
+                  <a:srgbClr val="F5C563"/>
+                </a:solidFill>
+              </a:defRPr>
+            </a:pPr>
+            <a:r>
+              <a:t>👑 QUALCOMM SNAPDRAGON® AI LAB  •  SNAPDRAGON ROYAL EDITION  •  45 TOPS HEXAGON NPU</a:t>
             </a:r>
           </a:p>
         </p:txBody>
@@ -3237,7 +3237,7 @@
             <a:pPr>
               <a:defRPr sz="2200" b="1">
                 <a:solidFill>
-                  <a:srgbClr val="0096D6"/>
+                  <a:srgbClr val="F5C563"/>
                 </a:solidFill>
               </a:defRPr>
             </a:pPr>
@@ -3309,11 +3309,11 @@
             <a:avLst/>
           </a:prstGeom>
           <a:solidFill>
-            <a:srgbClr val="0D1526"/>
+            <a:srgbClr val="0B1120"/>
           </a:solidFill>
           <a:ln>
             <a:solidFill>
-              <a:srgbClr val="00D9FF"/>
+              <a:srgbClr val="E5A93C"/>
             </a:solidFill>
           </a:ln>
         </p:spPr>
@@ -3338,7 +3338,7 @@
             <a:pPr algn="ctr">
               <a:defRPr sz="2400" b="1">
                 <a:solidFill>
-                  <a:srgbClr val="00D9FF"/>
+                  <a:srgbClr val="F5C563"/>
                 </a:solidFill>
               </a:defRPr>
             </a:pPr>
@@ -3375,11 +3375,11 @@
             <a:avLst/>
           </a:prstGeom>
           <a:solidFill>
-            <a:srgbClr val="0D1526"/>
+            <a:srgbClr val="0B1120"/>
           </a:solidFill>
           <a:ln>
             <a:solidFill>
-              <a:srgbClr val="00D9FF"/>
+              <a:srgbClr val="E5A93C"/>
             </a:solidFill>
           </a:ln>
         </p:spPr>
@@ -3404,7 +3404,7 @@
             <a:pPr algn="ctr">
               <a:defRPr sz="2400" b="1">
                 <a:solidFill>
-                  <a:srgbClr val="00D9FF"/>
+                  <a:srgbClr val="F5C563"/>
                 </a:solidFill>
               </a:defRPr>
             </a:pPr>
@@ -3441,11 +3441,11 @@
             <a:avLst/>
           </a:prstGeom>
           <a:solidFill>
-            <a:srgbClr val="0D1526"/>
+            <a:srgbClr val="0B1120"/>
           </a:solidFill>
           <a:ln>
             <a:solidFill>
-              <a:srgbClr val="00D9FF"/>
+              <a:srgbClr val="E5A93C"/>
             </a:solidFill>
           </a:ln>
         </p:spPr>
@@ -3470,7 +3470,7 @@
             <a:pPr algn="ctr">
               <a:defRPr sz="2400" b="1">
                 <a:solidFill>
-                  <a:srgbClr val="00D9FF"/>
+                  <a:srgbClr val="F5C563"/>
                 </a:solidFill>
               </a:defRPr>
             </a:pPr>
@@ -3525,11 +3525,11 @@
             <a:avLst/>
           </a:prstGeom>
           <a:solidFill>
-            <a:srgbClr val="070B14"/>
+            <a:srgbClr val="050811"/>
           </a:solidFill>
           <a:ln>
             <a:solidFill>
-              <a:srgbClr val="070B14"/>
+              <a:srgbClr val="050811"/>
             </a:solidFill>
           </a:ln>
         </p:spPr>
@@ -3580,13 +3580,13 @@
             <a:pPr>
               <a:defRPr sz="1100" b="1">
                 <a:solidFill>
-                  <a:srgbClr val="00D9FF"/>
+                  <a:srgbClr val="E5A93C"/>
                 </a:solidFill>
                 <a:latin typeface="Arial"/>
               </a:defRPr>
             </a:pPr>
             <a:r>
-              <a:t>CONCLUSION | HP OMNIBOOK X</a:t>
+              <a:t>👑 CONCLUSION | SNAPDRAGON ROYAL EDITION</a:t>
             </a:r>
           </a:p>
         </p:txBody>
@@ -3616,7 +3616,7 @@
             <a:pPr algn="r">
               <a:defRPr sz="1200" b="1">
                 <a:solidFill>
-                  <a:srgbClr val="94A3B8"/>
+                  <a:srgbClr val="F5C563"/>
                 </a:solidFill>
                 <a:latin typeface="Arial"/>
               </a:defRPr>
@@ -3678,11 +3678,11 @@
             <a:avLst/>
           </a:prstGeom>
           <a:solidFill>
-            <a:srgbClr val="0D1526"/>
+            <a:srgbClr val="0B1120"/>
           </a:solidFill>
           <a:ln>
             <a:solidFill>
-              <a:srgbClr val="00D9FF"/>
+              <a:srgbClr val="00F0FF"/>
             </a:solidFill>
           </a:ln>
         </p:spPr>
@@ -3707,7 +3707,7 @@
             <a:pPr algn="ctr">
               <a:defRPr sz="1600" b="1">
                 <a:solidFill>
-                  <a:srgbClr val="00D9FF"/>
+                  <a:srgbClr val="00F0FF"/>
                 </a:solidFill>
               </a:defRPr>
             </a:pPr>
@@ -3792,7 +3792,7 @@
             <a:avLst/>
           </a:prstGeom>
           <a:solidFill>
-            <a:srgbClr val="0D1526"/>
+            <a:srgbClr val="0B1120"/>
           </a:solidFill>
           <a:ln>
             <a:solidFill>
@@ -3904,7 +3904,7 @@
             <a:pPr algn="ctr">
               <a:defRPr sz="1400" b="1">
                 <a:solidFill>
-                  <a:srgbClr val="00D9FF"/>
+                  <a:srgbClr val="00F0FF"/>
                 </a:solidFill>
               </a:defRPr>
             </a:pPr>
@@ -3947,11 +3947,11 @@
             <a:avLst/>
           </a:prstGeom>
           <a:solidFill>
-            <a:srgbClr val="070B14"/>
+            <a:srgbClr val="050811"/>
           </a:solidFill>
           <a:ln>
             <a:solidFill>
-              <a:srgbClr val="070B14"/>
+              <a:srgbClr val="050811"/>
             </a:solidFill>
           </a:ln>
         </p:spPr>
@@ -4002,13 +4002,13 @@
             <a:pPr>
               <a:defRPr sz="1100" b="1">
                 <a:solidFill>
-                  <a:srgbClr val="00D9FF"/>
+                  <a:srgbClr val="E5A93C"/>
                 </a:solidFill>
                 <a:latin typeface="Arial"/>
               </a:defRPr>
             </a:pPr>
             <a:r>
-              <a:t>PROBLEM STATEMENT | HP OMNIBOOK X</a:t>
+              <a:t>👑 PROBLEM STATEMENT | SNAPDRAGON ROYAL EDITION</a:t>
             </a:r>
           </a:p>
         </p:txBody>
@@ -4038,7 +4038,7 @@
             <a:pPr algn="r">
               <a:defRPr sz="1200" b="1">
                 <a:solidFill>
-                  <a:srgbClr val="94A3B8"/>
+                  <a:srgbClr val="F5C563"/>
                 </a:solidFill>
                 <a:latin typeface="Arial"/>
               </a:defRPr>
@@ -4100,7 +4100,7 @@
             <a:avLst/>
           </a:prstGeom>
           <a:solidFill>
-            <a:srgbClr val="0D1526"/>
+            <a:srgbClr val="0B1120"/>
           </a:solidFill>
           <a:ln>
             <a:solidFill>
@@ -4202,7 +4202,7 @@
             <a:avLst/>
           </a:prstGeom>
           <a:solidFill>
-            <a:srgbClr val="0D1526"/>
+            <a:srgbClr val="0B1120"/>
           </a:solidFill>
           <a:ln>
             <a:solidFill>
@@ -4322,11 +4322,11 @@
             <a:avLst/>
           </a:prstGeom>
           <a:solidFill>
-            <a:srgbClr val="070B14"/>
+            <a:srgbClr val="050811"/>
           </a:solidFill>
           <a:ln>
             <a:solidFill>
-              <a:srgbClr val="070B14"/>
+              <a:srgbClr val="050811"/>
             </a:solidFill>
           </a:ln>
         </p:spPr>
@@ -4377,13 +4377,13 @@
             <a:pPr>
               <a:defRPr sz="1100" b="1">
                 <a:solidFill>
-                  <a:srgbClr val="00D9FF"/>
+                  <a:srgbClr val="E5A93C"/>
                 </a:solidFill>
                 <a:latin typeface="Arial"/>
               </a:defRPr>
             </a:pPr>
             <a:r>
-              <a:t>SOLUTION OVERVIEW | HP OMNIBOOK X</a:t>
+              <a:t>👑 SOLUTION OVERVIEW | SNAPDRAGON ROYAL EDITION</a:t>
             </a:r>
           </a:p>
         </p:txBody>
@@ -4413,7 +4413,7 @@
             <a:pPr algn="r">
               <a:defRPr sz="1200" b="1">
                 <a:solidFill>
-                  <a:srgbClr val="94A3B8"/>
+                  <a:srgbClr val="F5C563"/>
                 </a:solidFill>
                 <a:latin typeface="Arial"/>
               </a:defRPr>
@@ -4475,7 +4475,7 @@
             <a:avLst/>
           </a:prstGeom>
           <a:solidFill>
-            <a:srgbClr val="0D1526"/>
+            <a:srgbClr val="0B1120"/>
           </a:solidFill>
           <a:ln>
             <a:solidFill>
@@ -4589,7 +4589,7 @@
             <a:avLst/>
           </a:prstGeom>
           <a:solidFill>
-            <a:srgbClr val="0D1526"/>
+            <a:srgbClr val="0B1120"/>
           </a:solidFill>
           <a:ln>
             <a:solidFill>
@@ -4721,11 +4721,11 @@
             <a:avLst/>
           </a:prstGeom>
           <a:solidFill>
-            <a:srgbClr val="070B14"/>
+            <a:srgbClr val="050811"/>
           </a:solidFill>
           <a:ln>
             <a:solidFill>
-              <a:srgbClr val="070B14"/>
+              <a:srgbClr val="050811"/>
             </a:solidFill>
           </a:ln>
         </p:spPr>
@@ -4776,13 +4776,13 @@
             <a:pPr>
               <a:defRPr sz="1100" b="1">
                 <a:solidFill>
-                  <a:srgbClr val="00D9FF"/>
+                  <a:srgbClr val="E5A93C"/>
                 </a:solidFill>
                 <a:latin typeface="Arial"/>
               </a:defRPr>
             </a:pPr>
             <a:r>
-              <a:t>TECHNICAL IMPLEMENTATION | HP OMNIBOOK X</a:t>
+              <a:t>👑 TECHNICAL IMPLEMENTATION | SNAPDRAGON ROYAL EDITION</a:t>
             </a:r>
           </a:p>
         </p:txBody>
@@ -4812,7 +4812,7 @@
             <a:pPr algn="r">
               <a:defRPr sz="1200" b="1">
                 <a:solidFill>
-                  <a:srgbClr val="94A3B8"/>
+                  <a:srgbClr val="F5C563"/>
                 </a:solidFill>
                 <a:latin typeface="Arial"/>
               </a:defRPr>
@@ -4874,11 +4874,11 @@
             <a:avLst/>
           </a:prstGeom>
           <a:solidFill>
-            <a:srgbClr val="0D1526"/>
+            <a:srgbClr val="0B1120"/>
           </a:solidFill>
           <a:ln>
             <a:solidFill>
-              <a:srgbClr val="00D9FF"/>
+              <a:srgbClr val="00F0FF"/>
             </a:solidFill>
           </a:ln>
         </p:spPr>
@@ -4928,11 +4928,11 @@
             <a:avLst/>
           </a:prstGeom>
           <a:solidFill>
-            <a:srgbClr val="0D1526"/>
+            <a:srgbClr val="0B1120"/>
           </a:solidFill>
           <a:ln>
             <a:solidFill>
-              <a:srgbClr val="00D9FF"/>
+              <a:srgbClr val="00F0FF"/>
             </a:solidFill>
           </a:ln>
         </p:spPr>
@@ -4982,11 +4982,11 @@
             <a:avLst/>
           </a:prstGeom>
           <a:solidFill>
-            <a:srgbClr val="0D1526"/>
+            <a:srgbClr val="0B1120"/>
           </a:solidFill>
           <a:ln>
             <a:solidFill>
-              <a:srgbClr val="00D9FF"/>
+              <a:srgbClr val="00F0FF"/>
             </a:solidFill>
           </a:ln>
         </p:spPr>
@@ -5036,11 +5036,11 @@
             <a:avLst/>
           </a:prstGeom>
           <a:solidFill>
-            <a:srgbClr val="0D1526"/>
+            <a:srgbClr val="0B1120"/>
           </a:solidFill>
           <a:ln>
             <a:solidFill>
-              <a:srgbClr val="00D9FF"/>
+              <a:srgbClr val="00F0FF"/>
             </a:solidFill>
           </a:ln>
         </p:spPr>
@@ -5090,11 +5090,11 @@
             <a:avLst/>
           </a:prstGeom>
           <a:solidFill>
-            <a:srgbClr val="0D1526"/>
+            <a:srgbClr val="0B1120"/>
           </a:solidFill>
           <a:ln>
             <a:solidFill>
-              <a:srgbClr val="00D9FF"/>
+              <a:srgbClr val="00F0FF"/>
             </a:solidFill>
           </a:ln>
         </p:spPr>
@@ -5154,7 +5154,7 @@
             <a:pPr>
               <a:defRPr sz="1300" b="1">
                 <a:solidFill>
-                  <a:srgbClr val="00D9FF"/>
+                  <a:srgbClr val="00F0FF"/>
                 </a:solidFill>
               </a:defRPr>
             </a:pPr>
@@ -5197,11 +5197,11 @@
             <a:avLst/>
           </a:prstGeom>
           <a:solidFill>
-            <a:srgbClr val="070B14"/>
+            <a:srgbClr val="050811"/>
           </a:solidFill>
           <a:ln>
             <a:solidFill>
-              <a:srgbClr val="070B14"/>
+              <a:srgbClr val="050811"/>
             </a:solidFill>
           </a:ln>
         </p:spPr>
@@ -5252,13 +5252,13 @@
             <a:pPr>
               <a:defRPr sz="1100" b="1">
                 <a:solidFill>
-                  <a:srgbClr val="00D9FF"/>
+                  <a:srgbClr val="E5A93C"/>
                 </a:solidFill>
                 <a:latin typeface="Arial"/>
               </a:defRPr>
             </a:pPr>
             <a:r>
-              <a:t>HARDWARE INTEGRATION | HP OMNIBOOK X</a:t>
+              <a:t>👑 HARDWARE INTEGRATION | SNAPDRAGON ROYAL EDITION</a:t>
             </a:r>
           </a:p>
         </p:txBody>
@@ -5288,7 +5288,7 @@
             <a:pPr algn="r">
               <a:defRPr sz="1200" b="1">
                 <a:solidFill>
-                  <a:srgbClr val="94A3B8"/>
+                  <a:srgbClr val="F5C563"/>
                 </a:solidFill>
                 <a:latin typeface="Arial"/>
               </a:defRPr>
@@ -5350,7 +5350,7 @@
             <a:avLst/>
           </a:prstGeom>
           <a:solidFill>
-            <a:srgbClr val="0D1526"/>
+            <a:srgbClr val="0B1120"/>
           </a:solidFill>
           <a:ln>
             <a:solidFill>
@@ -5440,7 +5440,7 @@
             <a:avLst/>
           </a:prstGeom>
           <a:solidFill>
-            <a:srgbClr val="0D1526"/>
+            <a:srgbClr val="0B1120"/>
           </a:solidFill>
           <a:ln>
             <a:solidFill>
@@ -5530,11 +5530,11 @@
             <a:avLst/>
           </a:prstGeom>
           <a:solidFill>
-            <a:srgbClr val="0D1526"/>
+            <a:srgbClr val="0B1120"/>
           </a:solidFill>
           <a:ln>
             <a:solidFill>
-              <a:srgbClr val="00D9FF"/>
+              <a:srgbClr val="00F0FF"/>
             </a:solidFill>
           </a:ln>
         </p:spPr>
@@ -5559,7 +5559,7 @@
             <a:pPr algn="ctr">
               <a:defRPr sz="1600" b="1">
                 <a:solidFill>
-                  <a:srgbClr val="00D9FF"/>
+                  <a:srgbClr val="00F0FF"/>
                 </a:solidFill>
               </a:defRPr>
             </a:pPr>
@@ -5620,7 +5620,7 @@
             <a:avLst/>
           </a:prstGeom>
           <a:solidFill>
-            <a:srgbClr val="0D1526"/>
+            <a:srgbClr val="0B1120"/>
           </a:solidFill>
           <a:ln>
             <a:solidFill>
@@ -5728,11 +5728,11 @@
             <a:avLst/>
           </a:prstGeom>
           <a:solidFill>
-            <a:srgbClr val="070B14"/>
+            <a:srgbClr val="050811"/>
           </a:solidFill>
           <a:ln>
             <a:solidFill>
-              <a:srgbClr val="070B14"/>
+              <a:srgbClr val="050811"/>
             </a:solidFill>
           </a:ln>
         </p:spPr>
@@ -5783,13 +5783,13 @@
             <a:pPr>
               <a:defRPr sz="1100" b="1">
                 <a:solidFill>
-                  <a:srgbClr val="00D9FF"/>
+                  <a:srgbClr val="E5A93C"/>
                 </a:solidFill>
                 <a:latin typeface="Arial"/>
               </a:defRPr>
             </a:pPr>
             <a:r>
-              <a:t>CLINICAL &amp; REGULATORY INNOVATION | HP OMNIBOOK X</a:t>
+              <a:t>👑 CLINICAL &amp; REGULATORY INNOVATION | SNAPDRAGON ROYAL EDITION</a:t>
             </a:r>
           </a:p>
         </p:txBody>
@@ -5819,7 +5819,7 @@
             <a:pPr algn="r">
               <a:defRPr sz="1200" b="1">
                 <a:solidFill>
-                  <a:srgbClr val="94A3B8"/>
+                  <a:srgbClr val="F5C563"/>
                 </a:solidFill>
                 <a:latin typeface="Arial"/>
               </a:defRPr>
@@ -5881,11 +5881,11 @@
             <a:avLst/>
           </a:prstGeom>
           <a:solidFill>
-            <a:srgbClr val="0D1526"/>
+            <a:srgbClr val="0B1120"/>
           </a:solidFill>
           <a:ln>
             <a:solidFill>
-              <a:srgbClr val="00D9FF"/>
+              <a:srgbClr val="00F0FF"/>
             </a:solidFill>
           </a:ln>
         </p:spPr>
@@ -5910,12 +5910,12 @@
             <a:pPr algn="ctr">
               <a:defRPr sz="1600" b="1">
                 <a:solidFill>
-                  <a:srgbClr val="00D9FF"/>
-                </a:solidFill>
-              </a:defRPr>
-            </a:pPr>
-            <a:r>
-              <a:t>Clinical Explainable AI (XAI)</a:t>
+                  <a:srgbClr val="00F0FF"/>
+                </a:solidFill>
+              </a:defRPr>
+            </a:pPr>
+            <a:r>
+              <a:t>Clinical Explainable AI &amp; Equity Calibration</a:t>
             </a:r>
           </a:p>
           <a:p>
@@ -5927,7 +5927,7 @@
               </a:defRPr>
             </a:pPr>
             <a:r>
-              <a:t>• Transparent ABCD Dermatological Verification:</a:t>
+              <a:t>• Monk Skin Tone (MST 1-10) Adaptive Calibration: Overcomes 3x Fitzpatrick sensitivity collapse, achieving 98.7% cross-tone parity.</a:t>
             </a:r>
           </a:p>
           <a:p>
@@ -5939,7 +5939,7 @@
               </a:defRPr>
             </a:pPr>
             <a:r>
-              <a:t>•   • A (Asymmetry Index): Contour centroid variance formula.</a:t>
+              <a:t>• Pre-Inference Optical IQA: Gates image sharpness &amp; glare on NPU in &lt;10ms, eliminating Google Thailand unreadable-scan stalls.</a:t>
             </a:r>
           </a:p>
           <a:p>
@@ -5951,7 +5951,7 @@
               </a:defRPr>
             </a:pPr>
             <a:r>
-              <a:t>•   • B (Border Compactness): Isoperimetric quotient P^2 / (4*pi*A).</a:t>
+              <a:t>• Acoustic Friction Suppression: HP Poly Studio filtering (&lt;0.012 index) + respiratory phase gating rejects fake crackle artifacts.</a:t>
             </a:r>
           </a:p>
           <a:p>
@@ -5963,7 +5963,7 @@
               </a:defRPr>
             </a:pPr>
             <a:r>
-              <a:t>•   • C (Color Variegation): RGB and HSV Euclidean cluster variance.</a:t>
+              <a:t>• Epistemic Uncertainty Bounds: Temperature-scaled margin (±1.4-1.8%) delivers trust-calibrated confidence to physicians.</a:t>
             </a:r>
           </a:p>
           <a:p>
@@ -5975,31 +5975,7 @@
               </a:defRPr>
             </a:pPr>
             <a:r>
-              <a:t>•   • D (Diameter): Calibrated caliber measuring &gt; 6.0 mm threshold.</a:t>
-            </a:r>
-          </a:p>
-          <a:p>
-            <a:pPr>
-              <a:defRPr sz="1300">
-                <a:solidFill>
-                  <a:srgbClr val="F8FAFC"/>
-                </a:solidFill>
-              </a:defRPr>
-            </a:pPr>
-            <a:r>
-              <a:t>• Grad-CAM Visual Attention Heatmap: Interactive slider overlaying gradient activation clusters directly over lesion borders.</a:t>
-            </a:r>
-          </a:p>
-          <a:p>
-            <a:pPr>
-              <a:defRPr sz="1300">
-                <a:solidFill>
-                  <a:srgbClr val="F8FAFC"/>
-                </a:solidFill>
-              </a:defRPr>
-            </a:pPr>
-            <a:r>
-              <a:t>• Builds clinical trust by eliminating black-box opacity for doctors.</a:t>
+              <a:t>• ABCD Dermatological Rule + Grad-CAM Heatmaps: Eliminates black-box opacity with clear mathematical and visual proof.</a:t>
             </a:r>
           </a:p>
         </p:txBody>
@@ -6019,7 +5995,7 @@
             <a:avLst/>
           </a:prstGeom>
           <a:solidFill>
-            <a:srgbClr val="0D1526"/>
+            <a:srgbClr val="0B1120"/>
           </a:solidFill>
           <a:ln>
             <a:solidFill>
@@ -6151,11 +6127,11 @@
             <a:avLst/>
           </a:prstGeom>
           <a:solidFill>
-            <a:srgbClr val="070B14"/>
+            <a:srgbClr val="050811"/>
           </a:solidFill>
           <a:ln>
             <a:solidFill>
-              <a:srgbClr val="070B14"/>
+              <a:srgbClr val="050811"/>
             </a:solidFill>
           </a:ln>
         </p:spPr>
@@ -6206,13 +6182,13 @@
             <a:pPr>
               <a:defRPr sz="1100" b="1">
                 <a:solidFill>
-                  <a:srgbClr val="00D9FF"/>
+                  <a:srgbClr val="E5A93C"/>
                 </a:solidFill>
                 <a:latin typeface="Arial"/>
               </a:defRPr>
             </a:pPr>
             <a:r>
-              <a:t>VALIDATION &amp; BENCHMARKS | HP OMNIBOOK X</a:t>
+              <a:t>👑 VALIDATION &amp; BENCHMARKS | SNAPDRAGON ROYAL EDITION</a:t>
             </a:r>
           </a:p>
         </p:txBody>
@@ -6242,7 +6218,7 @@
             <a:pPr algn="r">
               <a:defRPr sz="1200" b="1">
                 <a:solidFill>
-                  <a:srgbClr val="94A3B8"/>
+                  <a:srgbClr val="F5C563"/>
                 </a:solidFill>
                 <a:latin typeface="Arial"/>
               </a:defRPr>
@@ -6304,11 +6280,11 @@
             <a:avLst/>
           </a:prstGeom>
           <a:solidFill>
-            <a:srgbClr val="0D1526"/>
+            <a:srgbClr val="0B1120"/>
           </a:solidFill>
           <a:ln>
             <a:solidFill>
-              <a:srgbClr val="00D9FF"/>
+              <a:srgbClr val="00F0FF"/>
             </a:solidFill>
           </a:ln>
         </p:spPr>
@@ -6358,11 +6334,11 @@
             <a:avLst/>
           </a:prstGeom>
           <a:solidFill>
-            <a:srgbClr val="0D1526"/>
+            <a:srgbClr val="0B1120"/>
           </a:solidFill>
           <a:ln>
             <a:solidFill>
-              <a:srgbClr val="00D9FF"/>
+              <a:srgbClr val="00F0FF"/>
             </a:solidFill>
           </a:ln>
         </p:spPr>
@@ -6412,11 +6388,11 @@
             <a:avLst/>
           </a:prstGeom>
           <a:solidFill>
-            <a:srgbClr val="0D1526"/>
+            <a:srgbClr val="0B1120"/>
           </a:solidFill>
           <a:ln>
             <a:solidFill>
-              <a:srgbClr val="00D9FF"/>
+              <a:srgbClr val="00F0FF"/>
             </a:solidFill>
           </a:ln>
         </p:spPr>
@@ -6466,11 +6442,11 @@
             <a:avLst/>
           </a:prstGeom>
           <a:solidFill>
-            <a:srgbClr val="0D1526"/>
+            <a:srgbClr val="0B1120"/>
           </a:solidFill>
           <a:ln>
             <a:solidFill>
-              <a:srgbClr val="00D9FF"/>
+              <a:srgbClr val="00F0FF"/>
             </a:solidFill>
           </a:ln>
         </p:spPr>
@@ -6520,11 +6496,11 @@
             <a:avLst/>
           </a:prstGeom>
           <a:solidFill>
-            <a:srgbClr val="0D1526"/>
+            <a:srgbClr val="0B1120"/>
           </a:solidFill>
           <a:ln>
             <a:solidFill>
-              <a:srgbClr val="00D9FF"/>
+              <a:srgbClr val="00F0FF"/>
             </a:solidFill>
           </a:ln>
         </p:spPr>
@@ -6574,11 +6550,11 @@
             <a:avLst/>
           </a:prstGeom>
           <a:solidFill>
-            <a:srgbClr val="0D1526"/>
+            <a:srgbClr val="0B1120"/>
           </a:solidFill>
           <a:ln>
             <a:solidFill>
-              <a:srgbClr val="00D9FF"/>
+              <a:srgbClr val="00F0FF"/>
             </a:solidFill>
           </a:ln>
         </p:spPr>
@@ -6646,11 +6622,11 @@
             <a:avLst/>
           </a:prstGeom>
           <a:solidFill>
-            <a:srgbClr val="070B14"/>
+            <a:srgbClr val="050811"/>
           </a:solidFill>
           <a:ln>
             <a:solidFill>
-              <a:srgbClr val="070B14"/>
+              <a:srgbClr val="050811"/>
             </a:solidFill>
           </a:ln>
         </p:spPr>
@@ -6701,13 +6677,13 @@
             <a:pPr>
               <a:defRPr sz="1100" b="1">
                 <a:solidFill>
-                  <a:srgbClr val="00D9FF"/>
+                  <a:srgbClr val="E5A93C"/>
                 </a:solidFill>
                 <a:latin typeface="Arial"/>
               </a:defRPr>
             </a:pPr>
             <a:r>
-              <a:t>COMMERCIAL VIABILITY | HP OMNIBOOK X</a:t>
+              <a:t>👑 COMMERCIAL VIABILITY | SNAPDRAGON ROYAL EDITION</a:t>
             </a:r>
           </a:p>
         </p:txBody>
@@ -6737,7 +6713,7 @@
             <a:pPr algn="r">
               <a:defRPr sz="1200" b="1">
                 <a:solidFill>
-                  <a:srgbClr val="94A3B8"/>
+                  <a:srgbClr val="F5C563"/>
                 </a:solidFill>
                 <a:latin typeface="Arial"/>
               </a:defRPr>
@@ -6799,7 +6775,7 @@
             <a:avLst/>
           </a:prstGeom>
           <a:solidFill>
-            <a:srgbClr val="0D1526"/>
+            <a:srgbClr val="0B1120"/>
           </a:solidFill>
           <a:ln>
             <a:solidFill>
@@ -6828,7 +6804,7 @@
             <a:pPr algn="ctr">
               <a:defRPr sz="2800" b="1">
                 <a:solidFill>
-                  <a:srgbClr val="00D9FF"/>
+                  <a:srgbClr val="00F0FF"/>
                 </a:solidFill>
               </a:defRPr>
             </a:pPr>
@@ -6865,7 +6841,7 @@
             <a:avLst/>
           </a:prstGeom>
           <a:solidFill>
-            <a:srgbClr val="0D1526"/>
+            <a:srgbClr val="0B1120"/>
           </a:solidFill>
           <a:ln>
             <a:solidFill>
@@ -6894,7 +6870,7 @@
             <a:pPr algn="ctr">
               <a:defRPr sz="2800" b="1">
                 <a:solidFill>
-                  <a:srgbClr val="00D9FF"/>
+                  <a:srgbClr val="00F0FF"/>
                 </a:solidFill>
               </a:defRPr>
             </a:pPr>
@@ -6931,7 +6907,7 @@
             <a:avLst/>
           </a:prstGeom>
           <a:solidFill>
-            <a:srgbClr val="0D1526"/>
+            <a:srgbClr val="0B1120"/>
           </a:solidFill>
           <a:ln>
             <a:solidFill>
@@ -6960,7 +6936,7 @@
             <a:pPr algn="ctr">
               <a:defRPr sz="2800" b="1">
                 <a:solidFill>
-                  <a:srgbClr val="00D9FF"/>
+                  <a:srgbClr val="00F0FF"/>
                 </a:solidFill>
               </a:defRPr>
             </a:pPr>
@@ -6997,7 +6973,7 @@
             <a:avLst/>
           </a:prstGeom>
           <a:solidFill>
-            <a:srgbClr val="0D1526"/>
+            <a:srgbClr val="0B1120"/>
           </a:solidFill>
           <a:ln>
             <a:solidFill>
@@ -7117,11 +7093,11 @@
             <a:avLst/>
           </a:prstGeom>
           <a:solidFill>
-            <a:srgbClr val="070B14"/>
+            <a:srgbClr val="050811"/>
           </a:solidFill>
           <a:ln>
             <a:solidFill>
-              <a:srgbClr val="070B14"/>
+              <a:srgbClr val="050811"/>
             </a:solidFill>
           </a:ln>
         </p:spPr>
@@ -7172,13 +7148,13 @@
             <a:pPr>
               <a:defRPr sz="1100" b="1">
                 <a:solidFill>
-                  <a:srgbClr val="00D9FF"/>
+                  <a:srgbClr val="E5A93C"/>
                 </a:solidFill>
                 <a:latin typeface="Arial"/>
               </a:defRPr>
             </a:pPr>
             <a:r>
-              <a:t>EXPANSION &amp; MILESTONES | HP OMNIBOOK X</a:t>
+              <a:t>👑 EXPANSION &amp; MILESTONES | SNAPDRAGON ROYAL EDITION</a:t>
             </a:r>
           </a:p>
         </p:txBody>
@@ -7208,7 +7184,7 @@
             <a:pPr algn="r">
               <a:defRPr sz="1200" b="1">
                 <a:solidFill>
-                  <a:srgbClr val="94A3B8"/>
+                  <a:srgbClr val="F5C563"/>
                 </a:solidFill>
                 <a:latin typeface="Arial"/>
               </a:defRPr>
@@ -7270,11 +7246,11 @@
             <a:avLst/>
           </a:prstGeom>
           <a:solidFill>
-            <a:srgbClr val="0D1526"/>
+            <a:srgbClr val="0B1120"/>
           </a:solidFill>
           <a:ln>
             <a:solidFill>
-              <a:srgbClr val="00D9FF"/>
+              <a:srgbClr val="00F0FF"/>
             </a:solidFill>
           </a:ln>
         </p:spPr>
@@ -7299,7 +7275,7 @@
             <a:pPr algn="ctr">
               <a:defRPr sz="1600" b="1">
                 <a:solidFill>
-                  <a:srgbClr val="00D9FF"/>
+                  <a:srgbClr val="00F0FF"/>
                 </a:solidFill>
               </a:defRPr>
             </a:pPr>
@@ -7348,7 +7324,7 @@
             <a:avLst/>
           </a:prstGeom>
           <a:solidFill>
-            <a:srgbClr val="0D1526"/>
+            <a:srgbClr val="0B1120"/>
           </a:solidFill>
           <a:ln>
             <a:solidFill>
@@ -7426,7 +7402,7 @@
             <a:avLst/>
           </a:prstGeom>
           <a:solidFill>
-            <a:srgbClr val="0D1526"/>
+            <a:srgbClr val="0B1120"/>
           </a:solidFill>
           <a:ln>
             <a:solidFill>

</xml_diff>